<commit_message>
Claim repairs after the independent development review (9 Oct): exact identity D = (1 + gV)(m1 - m0)/m0 everywhere; 26 vs 27 foreign-firm selection named; month check on the same start-year groups (part-year selling still falls; diagnostic, not closed); story, pitch (dated note), arc and deck wording brought to what the evidence shows; review package committed; rebuild 272/272
Co-Authored-By: Claude Opus 5.5 <noreply@anthropic.com>
</commit_message>
<xml_diff>
--- a/research/option_space_2026-10-01/deck/IL_Progress_Update_2026-10-09.pptx
+++ b/research/option_space_2026-10-01/deck/IL_Progress_Update_2026-10-09.pptx
@@ -120,48 +120,48 @@
   <p:extLst>
     <p:ext uri="{521415D9-36F7-43E2-AB2F-B90AF26B5E84}">
       <p14:sectionLst xmlns:p14="http://schemas.microsoft.com/office/powerpoint/2010/main">
-        <p14:section name="Opening" id="{9cf0d95b-1368-4a38-957b-1f0e537ad884}">
+        <p14:section name="Opening" id="{5e8bc689-4f8a-f688-bbfc-561c532d8e5d}">
           <p14:sldIdLst>
             <p14:sldId id="256"/>
             <p14:sldId id="257"/>
             <p14:sldId id="258"/>
           </p14:sldIdLst>
         </p14:section>
-        <p14:section name="How it reads" id="{1f5f2c2a-6a11-9a94-1285-7bbb2bf213ad}">
+        <p14:section name="How it reads" id="{943466c2-cf85-2884-f165-952d81aafa0d}">
           <p14:sldIdLst>
             <p14:sldId id="259"/>
             <p14:sldId id="260"/>
           </p14:sldIdLst>
         </p14:section>
-        <p14:section name="Platforms" id="{08178618-5cca-4655-0980-9000eacd5993}">
+        <p14:section name="Platforms" id="{a98522a7-84e1-9a0d-fd37-89321b95fe11}">
           <p14:sldIdLst>
             <p14:sldId id="261"/>
           </p14:sldIdLst>
         </p14:section>
-        <p14:section name="2023" id="{d61c68cd-2bcb-4f4a-6fe2-bad108ef004f}">
+        <p14:section name="2023" id="{ad89adf8-eeca-7645-b245-72ae23abbc02}">
           <p14:sldIdLst>
             <p14:sldId id="262"/>
           </p14:sldIdLst>
         </p14:section>
-        <p14:section name="Sellers" id="{e97690c9-bb15-f8b3-42c1-fd69e4d79f35}">
+        <p14:section name="Sellers" id="{05e7a1fd-0bb0-84cd-cbee-d3796086555b}">
           <p14:sldIdLst>
             <p14:sldId id="263"/>
             <p14:sldId id="264"/>
             <p14:sldId id="265"/>
           </p14:sldIdLst>
         </p14:section>
-        <p14:section name="Why it matters" id="{e9003f71-370b-8092-18b6-8ef0aff26bdf}">
+        <p14:section name="Why it matters" id="{c4f0d2bb-4eab-1fea-3b08-4f146fe07c8a}">
           <p14:sldIdLst>
             <p14:sldId id="266"/>
           </p14:sldIdLst>
         </p14:section>
-        <p14:section name="Answers" id="{4b9859d4-a02e-2cbe-6243-03007b3595b6}">
+        <p14:section name="Answers" id="{ef0bc934-e5b2-c4fc-20e8-f5e29ab00f3c}">
           <p14:sldIdLst>
             <p14:sldId id="267"/>
             <p14:sldId id="268"/>
           </p14:sldIdLst>
         </p14:section>
-        <p14:section name="Next" id="{a3aee36f-6665-7502-3893-2361704a2bec}">
+        <p14:section name="Next" id="{7454ebc8-1455-4ce7-6a57-32452e4027a5}">
           <p14:sldIdLst>
             <p14:sldId id="269"/>
           </p14:sldIdLst>
@@ -658,7 +658,7 @@
           <a:p>
             <a:r>
               <a:rPr lang="en-US" dirty="0"/>
-              <a:t>The open alternative to wider survey reach is sellers who paused in 2022 and came back. Three answers: the month pattern, the timing, and who closes and restarts small firms. January restarts cannot be ruled out; the claim stays 'the likeliest reading'.</a:t>
+              <a:t>The open alternative to wider survey reach is sellers who paused in 2022 and came back. Three checks weigh against it: the month pattern within the same start-year groups, the timing, and who closes and restarts small firms. Without linked histories, returns can be offset by exits or by sellers moving to full-year selling, and January returns are possible, so the alternative stays open.</a:t>
             </a:r>
             <a:endParaRPr lang="en-US" dirty="0"/>
           </a:p>
@@ -1450,7 +1450,7 @@
           <a:p>
             <a:r>
               <a:rPr lang="en-US" dirty="0"/>
-              <a:t>Answers Thomas's question on the wedge. Growth divergence equals the change in the share kept divided by the share kept, so the size of the wedge next to revenue sets how far a price change moves revenue growth. Exploratory check, h1_points_vs_log.py. It also corrects our own earlier wording.</a:t>
+              <a:t>Answers Thomas's question on the wedge. Exactly, growth divergence D = (1 + gV)(m1 - m0)/m0: the amplifier is 1/m0 = 1 + E0, together with transaction growth. So the size of the wedge next to revenue sets how far a price change moves revenue growth. Exploratory check, h1_points_vs_log.py. It also corrects our own earlier wording.</a:t>
             </a:r>
             <a:endParaRPr lang="en-US" dirty="0"/>
           </a:p>
@@ -2752,7 +2752,7 @@
                 <a:ea typeface="Montserrat" pitchFamily="34" charset="-122"/>
                 <a:cs typeface="Montserrat" pitchFamily="34" charset="-120"/>
               </a:rPr>
-              <a:t>Not sellers coming back from a break</a:t>
+              <a:t>Sellers back from a break: checked, not closed</a:t>
             </a:r>
             <a:endParaRPr lang="en-US" sz="2600" dirty="0"/>
           </a:p>
@@ -2793,7 +2793,7 @@
                 <a:ea typeface="Calibri" pitchFamily="34" charset="-122"/>
                 <a:cs typeface="Calibri" pitchFamily="34" charset="-120"/>
               </a:rPr>
-              <a:t>“Someone back from a break sells for part of the year. The rise is in sellers who sold every month.”</a:t>
+              <a:t>“Part-year selling fell, even within the same start-year groups.”</a:t>
             </a:r>
             <a:endParaRPr lang="en-US" sz="1500" dirty="0"/>
           </a:p>
@@ -2859,7 +2859,7 @@
                 <a:ea typeface="Calibri" pitchFamily="34" charset="-122"/>
                 <a:cs typeface="Calibri" pitchFamily="34" charset="-120"/>
               </a:rPr>
-              <a:t>THREE ANSWERS</a:t>
+              <a:t>THREE CHECKS</a:t>
             </a:r>
             <a:endParaRPr lang="en-US" sz="1100" dirty="0"/>
           </a:p>
@@ -2918,7 +2918,7 @@
                 <a:ea typeface="Calibri" pitchFamily="34" charset="-122"/>
                 <a:cs typeface="Calibri" pitchFamily="34" charset="-120"/>
               </a:rPr>
-              <a:t>part-year selling fell (472k to 403k); full-year selling rose (2.09m to 2.90m).</a:t>
+              <a:t>among sellers who started by 2021, part-year selling fell from 472k to 318k; it falls for every start-year group.</a:t>
             </a:r>
             <a:endParaRPr lang="en-US" sz="1400" dirty="0"/>
           </a:p>
@@ -2992,7 +2992,7 @@
                 <a:ea typeface="Calibri" pitchFamily="34" charset="-122"/>
                 <a:cs typeface="Calibri" pitchFamily="34" charset="-120"/>
               </a:rPr>
-              <a:t>small firms close most often when young, with young owners (McKenzie and Paffhausen 2019). These sellers are the opposite.</a:t>
+              <a:t>small firms close most often when young, with young owners (McKenzie and Paffhausen 2019). The extra count leans the other way. Returns stay the open alternative.</a:t>
             </a:r>
             <a:endParaRPr lang="en-US" sz="1400" dirty="0"/>
           </a:p>
@@ -3034,7 +3034,7 @@
                 <a:ea typeface="Calibri" pitchFamily="34" charset="-122"/>
                 <a:cs typeface="Calibri" pitchFamily="34" charset="-120"/>
               </a:rPr>
-              <a:t>BPS survey microdata; the month question changed format between rounds. Recall error would inflate first-time entry, so the estimate is conservative (Neter and Waksberg 1964).</a:t>
+              <a:t>BPS survey microdata; the month question changed format between rounds. If recall errors run forward, as in Neter and Waksberg (1964), the entry shortfall is conservative.</a:t>
             </a:r>
             <a:endParaRPr lang="en-US" sz="1000" dirty="0"/>
           </a:p>
@@ -4732,7 +4732,7 @@
                 <a:ea typeface="Calibri" pitchFamily="34" charset="-122"/>
                 <a:cs typeface="Calibri" pitchFamily="34" charset="-120"/>
               </a:rPr>
-              <a:t>Same price changes in rupiah; a much thinner slice</a:t>
+              <a:t>Similar changes in rupiah; a much thinner slice</a:t>
             </a:r>
             <a:endParaRPr lang="en-US" sz="1400" dirty="0"/>
           </a:p>
@@ -6679,7 +6679,7 @@
                 <a:ea typeface="Calibri" pitchFamily="34" charset="-122"/>
                 <a:cs typeface="Calibri" pitchFamily="34" charset="-120"/>
               </a:rPr>
-              <a:t>The wedge has a job: it explains why revenue swings</a:t>
+              <a:t>The wedge has a job: it helps explain why revenue swings</a:t>
             </a:r>
             <a:endParaRPr lang="en-US" sz="1400" dirty="0"/>
           </a:p>
@@ -6700,7 +6700,7 @@
                 <a:ea typeface="Calibri" pitchFamily="34" charset="-122"/>
                 <a:cs typeface="Calibri" pitchFamily="34" charset="-120"/>
               </a:rPr>
-              <a:t>H2's meaning: about half the 2023 rise in sellers was not new</a:t>
+              <a:t>H2's meaning: about half the 2023 rise in sellers was not first-time entry</a:t>
             </a:r>
             <a:endParaRPr lang="en-US" sz="1400" dirty="0"/>
           </a:p>
@@ -7029,7 +7029,7 @@
                 <a:ea typeface="Calibri" pitchFamily="34" charset="-122"/>
                 <a:cs typeface="Calibri" pitchFamily="34" charset="-120"/>
               </a:rPr>
-              <a:t>In 2023 Indonesia argued about whether online selling was growing so fast it was hurting market traders, and the government shut TikTok Shop. The official figures for that year later said online sales rose 41%. I looked inside the survey behind those figures. Most sellers said their sales were flat or down, and their main complaint was a lack of customers. About half the new sellers weren't new: they were older, long-running small businesses, selling through WhatsApp and social media, that were only counted that year. On the big platforms, revenue grew mostly because they charged more, not because people bought more.</a:t>
+              <a:t>In 2023 Indonesia argued about whether online selling was growing so fast it was hurting market traders, and the government shut TikTok Shop. The official figures for that year later said online sales rose 41%. I looked inside the survey behind those figures. Most sellers said their sales were flat or down, and their main complaint was a lack of customers. About half the new sellers weren't first-time sellers: the extra count leaned toward older, long-running small businesses selling through WhatsApp and social media. On the big platforms, revenue grew mostly because they charged more, not because people bought more.</a:t>
             </a:r>
             <a:endParaRPr lang="en-US" sz="1800" dirty="0"/>
           </a:p>
@@ -7088,7 +7088,7 @@
                 <a:ea typeface="Calibri" pitchFamily="34" charset="-122"/>
                 <a:cs typeface="Calibri" pitchFamily="34" charset="-120"/>
               </a:rPr>
-              <a:t>less commerce had moved online in 2023 than the numbers suggested. Platform income measured prices; the official seller count partly measured counting.</a:t>
+              <a:t>less commerce had moved online in 2023 than the headlines suggested. Platform income followed prices; the official seller count rose by more than first-time entry can explain.</a:t>
             </a:r>
             <a:endParaRPr lang="en-US" sz="1400" dirty="0"/>
           </a:p>
@@ -9876,7 +9876,7 @@
                 <a:ea typeface="Montserrat" pitchFamily="34" charset="-122"/>
                 <a:cs typeface="Montserrat" pitchFamily="34" charset="-120"/>
               </a:rPr>
-              <a:t>The wedge's job: same price changes, thinner slice</a:t>
+              <a:t>The wedge's job: similar price changes, thinner slice</a:t>
             </a:r>
             <a:endParaRPr lang="en-US" sz="2600" dirty="0"/>
           </a:p>
@@ -9917,7 +9917,7 @@
                 <a:ea typeface="Calibri" pitchFamily="34" charset="-122"/>
                 <a:cs typeface="Calibri" pitchFamily="34" charset="-120"/>
               </a:rPr>
-              <a:t>“Indonesian platforms did not change their prices more than platforms abroad. Their slice is ten times thinner.”</a:t>
+              <a:t>“In rupiah, Indonesian platforms' changes were close to those abroad. Their slice is ten times thinner.”</a:t>
             </a:r>
             <a:endParaRPr lang="en-US" sz="1500" dirty="0"/>
           </a:p>
@@ -10000,7 +10000,7 @@
                 <a:ea typeface="Calibri" pitchFamily="34" charset="-122"/>
                 <a:cs typeface="Calibri" pitchFamily="34" charset="-120"/>
               </a:rPr>
-              <a:t>a typical platform abroad keeps about 17 rupiah of every 100 sold; Indonesian marketplaces keep under 2. Both change what they keep by about 1 rupiah per 100 a year. On a 2-rupiah slice that is a huge change, so revenue growth swings about three times as much. H1 is still rejected; the reason is now clear.</a:t>
+              <a:t>a typical platform abroad keeps about 17 rupiah of every 100 sold; Indonesian marketplaces keep under 2. Both change what they keep by about 1 rupiah per 100 a year. On a 2-rupiah slice that is a huge change, so revenue growth swings about three times as much. H1 is still rejected; a thin slice helps explain why.</a:t>
             </a:r>
             <a:endParaRPr lang="en-US" sz="1400" dirty="0"/>
           </a:p>
@@ -10525,7 +10525,7 @@
                 <a:ea typeface="Montserrat" pitchFamily="34" charset="-122"/>
                 <a:cs typeface="Montserrat" pitchFamily="34" charset="-120"/>
               </a:rPr>
-              <a:t>H2 holds on paper; underneath, half were not new</a:t>
+              <a:t>H2 holds on paper; half the rise was not new entry</a:t>
             </a:r>
             <a:endParaRPr lang="en-US" sz="2600" dirty="0"/>
           </a:p>
@@ -10738,7 +10738,7 @@
                 <a:ea typeface="Calibri" pitchFamily="34" charset="-122"/>
                 <a:cs typeface="Calibri" pitchFamily="34" charset="-120"/>
               </a:rPr>
-              <a:t>Too large for chance (4.6 standard errors); follows where the survey grew; 2024 is normal again</a:t>
+              <a:t>Large in the sampling-error scenarios checked; follows where the survey grew; 2024 is normal again</a:t>
             </a:r>
             <a:endParaRPr lang="en-US" sz="1300" dirty="0"/>
           </a:p>
@@ -10994,7 +10994,7 @@
                 <a:ea typeface="Calibri" pitchFamily="34" charset="-122"/>
                 <a:cs typeface="Calibri" pitchFamily="34" charset="-120"/>
               </a:rPr>
-              <a:t>“Long-running small businesses, not start-ups. They had been there all along; the count reached them in 2023.”</a:t>
+              <a:t>“The larger count was concentrated among older, long-running businesses selling through chat and social media.”</a:t>
             </a:r>
             <a:endParaRPr lang="en-US" sz="1500" dirty="0"/>
           </a:p>
@@ -11208,7 +11208,7 @@
                 <a:ea typeface="Calibri" pitchFamily="34" charset="-122"/>
                 <a:cs typeface="Calibri" pitchFamily="34" charset="-120"/>
               </a:rPr>
-              <a:t>These are the people the original question was about: real business the numbers missed.</a:t>
+              <a:t>These are the kind of businesses the original question was about: real, long-running, and easy for the numbers to miss.</a:t>
             </a:r>
             <a:endParaRPr lang="en-US" sz="1400" dirty="0"/>
           </a:p>

</xml_diff>